<commit_message>
docs(sap): add explicit FI CO AA glossary
</commit_message>
<xml_diff>
--- a/docs/guides/SAP-CashPilot-User-Guide-10-Cas-Usage.pptx
+++ b/docs/guides/SAP-CashPilot-User-Guide-10-Cas-Usage.pptx
@@ -20,6 +20,7 @@
     <p:sldId id="268" r:id="rId19"/>
     <p:sldId id="269" r:id="rId20"/>
     <p:sldId id="270" r:id="rId21"/>
+    <p:sldId id="271" r:id="rId22"/>
   </p:sldIdLst>
   <p:sldSz cx="12191695" cy="6858000" type="screen4x3"/>
   <p:notesSz cx="6858000" cy="9144000"/>
@@ -3398,7 +3399,7 @@
                   <a:srgbClr val="FFFFFF"/>
                 </a:solidFill>
               </a:rPr>
-              <a:t>Cas d'usage 6: Preparation audit interne/externe</a:t>
+              <a:t>Cas d'usage 5: Preparation de cloture periodique</a:t>
             </a:r>
           </a:p>
         </p:txBody>
@@ -3469,7 +3470,7 @@
               </a:defRPr>
             </a:pPr>
             <a:r>
-              <a:t>Besoin de preuves de pilotage et de conformite.</a:t>
+              <a:t>Clotures tardives et charge de fin de mois trop elevee.</a:t>
             </a:r>
           </a:p>
         </p:txBody>
@@ -3540,7 +3541,7 @@
               </a:defRPr>
             </a:pPr>
             <a:r>
-              <a:t>Presenter score global, statuts modules et roadmap execution.</a:t>
+              <a:t>Utiliser module Close pour orchestrer checklist et dependances.</a:t>
             </a:r>
           </a:p>
         </p:txBody>
@@ -3611,7 +3612,7 @@
               </a:defRPr>
             </a:pPr>
             <a:r>
-              <a:t>Narratif d'audit clair avec traces de progression.</a:t>
+              <a:t>Cloture plus predicible et reduction des retards.</a:t>
             </a:r>
           </a:p>
           <a:p>
@@ -3626,7 +3627,7 @@
               </a:defRPr>
             </a:pPr>
             <a:r>
-              <a:t>Indicateurs: Global score, ratio done/blocked, historique generatedAt.</a:t>
+              <a:t>Indicateurs: Closures, latest closure, overdue proche de zero.</a:t>
             </a:r>
           </a:p>
         </p:txBody>
@@ -3720,7 +3721,7 @@
                   <a:srgbClr val="FFFFFF"/>
                 </a:solidFill>
               </a:rPr>
-              <a:t>Cas d'usage 7: Pilotage multi-societes</a:t>
+              <a:t>Cas d'usage 6: Preparation audit interne/externe</a:t>
             </a:r>
           </a:p>
         </p:txBody>
@@ -3791,7 +3792,7 @@
               </a:defRPr>
             </a:pPr>
             <a:r>
-              <a:t>Croissance du groupe et complexite intercompany.</a:t>
+              <a:t>Besoin de preuves de pilotage et de conformite.</a:t>
             </a:r>
           </a:p>
         </p:txBody>
@@ -3862,7 +3863,7 @@
               </a:defRPr>
             </a:pPr>
             <a:r>
-              <a:t>Piloter module Consolidation et relier portfolios/members.</a:t>
+              <a:t>Presenter score global, statuts modules et roadmap execution.</a:t>
             </a:r>
           </a:p>
         </p:txBody>
@@ -3933,7 +3934,7 @@
               </a:defRPr>
             </a:pPr>
             <a:r>
-              <a:t>Vision groupe harmonisee et meilleure maitrise des interco.</a:t>
+              <a:t>Narratif d'audit clair avec traces de progression.</a:t>
             </a:r>
           </a:p>
           <a:p>
@@ -3948,7 +3949,7 @@
               </a:defRPr>
             </a:pPr>
             <a:r>
-              <a:t>Indicateurs: Portfolios, members, score Consolidation.</a:t>
+              <a:t>Indicateurs: Global score, ratio done/blocked, historique generatedAt.</a:t>
             </a:r>
           </a:p>
         </p:txBody>
@@ -4042,7 +4043,7 @@
                   <a:srgbClr val="FFFFFF"/>
                 </a:solidFill>
               </a:rPr>
-              <a:t>Cas d'usage 8: Arbitrage capacite equipe finance</a:t>
+              <a:t>Cas d'usage 7: Pilotage multi-societes</a:t>
             </a:r>
           </a:p>
         </p:txBody>
@@ -4113,7 +4114,7 @@
               </a:defRPr>
             </a:pPr>
             <a:r>
-              <a:t>Trop d'initiatives en parallele sans priorisation robuste.</a:t>
+              <a:t>Croissance du groupe et complexite intercompany.</a:t>
             </a:r>
           </a:p>
         </p:txBody>
@@ -4184,7 +4185,7 @@
               </a:defRPr>
             </a:pPr>
             <a:r>
-              <a:t>Trier workstreams par statut, priorite et overdue dans le cockpit.</a:t>
+              <a:t>Piloter module Consolidation et relier portfolios/members.</a:t>
             </a:r>
           </a:p>
         </p:txBody>
@@ -4255,7 +4256,7 @@
               </a:defRPr>
             </a:pPr>
             <a:r>
-              <a:t>Roadmap realiste et sequence d'execution defendable.</a:t>
+              <a:t>Vision groupe harmonisee et meilleure maitrise des interco.</a:t>
             </a:r>
           </a:p>
           <a:p>
@@ -4270,7 +4271,7 @@
               </a:defRPr>
             </a:pPr>
             <a:r>
-              <a:t>Indicateurs: Blocked, overdue, completion_pct.</a:t>
+              <a:t>Indicateurs: Portfolios, members, score Consolidation.</a:t>
             </a:r>
           </a:p>
         </p:txBody>
@@ -4364,7 +4365,7 @@
                   <a:srgbClr val="FFFFFF"/>
                 </a:solidFill>
               </a:rPr>
-              <a:t>Cas d'usage 9: Onboarding d'un profil non-comptable</a:t>
+              <a:t>Cas d'usage 8: Arbitrage capacite equipe finance</a:t>
             </a:r>
           </a:p>
         </p:txBody>
@@ -4435,7 +4436,7 @@
               </a:defRPr>
             </a:pPr>
             <a:r>
-              <a:t>Un nouveau collaborateur doit contribuer aux flux finance.</a:t>
+              <a:t>Trop d'initiatives en parallele sans priorisation robuste.</a:t>
             </a:r>
           </a:p>
         </p:txBody>
@@ -4506,7 +4507,7 @@
               </a:defRPr>
             </a:pPr>
             <a:r>
-              <a:t>Parcours guide via bulles info + modules + actions roadmap simples.</a:t>
+              <a:t>Trier workstreams par statut, priorite et overdue dans le cockpit.</a:t>
             </a:r>
           </a:p>
         </p:txBody>
@@ -4577,7 +4578,7 @@
               </a:defRPr>
             </a:pPr>
             <a:r>
-              <a:t>Autonomie rapide sans surcharge de jargon technique.</a:t>
+              <a:t>Roadmap realiste et sequence d'execution defendable.</a:t>
             </a:r>
           </a:p>
           <a:p>
@@ -4592,7 +4593,7 @@
               </a:defRPr>
             </a:pPr>
             <a:r>
-              <a:t>Indicateurs: Temps d'onboarding, erreurs operationnelles, done par sprint.</a:t>
+              <a:t>Indicateurs: Blocked, overdue, completion_pct.</a:t>
             </a:r>
           </a:p>
         </p:txBody>
@@ -4686,7 +4687,7 @@
                   <a:srgbClr val="FFFFFF"/>
                 </a:solidFill>
               </a:rPr>
-              <a:t>Cas d'usage 10: Revue mensuelle de direction</a:t>
+              <a:t>Cas d'usage 9: Onboarding d'un profil non-comptable</a:t>
             </a:r>
           </a:p>
         </p:txBody>
@@ -4757,7 +4758,7 @@
               </a:defRPr>
             </a:pPr>
             <a:r>
-              <a:t>Direction souhaite un etat de progression finance lisible.</a:t>
+              <a:t>Un nouveau collaborateur doit contribuer aux flux finance.</a:t>
             </a:r>
           </a:p>
         </p:txBody>
@@ -4828,7 +4829,7 @@
               </a:defRPr>
             </a:pPr>
             <a:r>
-              <a:t>Utiliser cockpit comme support de comite: score, risques, plan suivant.</a:t>
+              <a:t>Parcours guide via bulles info + modules + actions roadmap simples.</a:t>
             </a:r>
           </a:p>
         </p:txBody>
@@ -4899,7 +4900,7 @@
               </a:defRPr>
             </a:pPr>
             <a:r>
-              <a:t>Decisions plus rapides et alignement transversal.</a:t>
+              <a:t>Autonomie rapide sans surcharge de jargon technique.</a:t>
             </a:r>
           </a:p>
           <a:p>
@@ -4914,7 +4915,7 @@
               </a:defRPr>
             </a:pPr>
             <a:r>
-              <a:t>Indicateurs: Global score, top 3 risques, plan du mois suivant valide.</a:t>
+              <a:t>Indicateurs: Temps d'onboarding, erreurs operationnelles, done par sprint.</a:t>
             </a:r>
           </a:p>
         </p:txBody>
@@ -5008,6 +5009,328 @@
                   <a:srgbClr val="FFFFFF"/>
                 </a:solidFill>
               </a:rPr>
+              <a:t>Cas d'usage 10: Revue mensuelle de direction</a:t>
+            </a:r>
+          </a:p>
+        </p:txBody>
+      </p:sp>
+      <p:sp>
+        <p:nvSpPr>
+          <p:cNvPr id="3" name="TextBox 2"/>
+          <p:cNvSpPr txBox="1"/>
+          <p:nvPr/>
+        </p:nvSpPr>
+        <p:spPr>
+          <a:xfrm>
+            <a:off x="640080" y="1828800"/>
+            <a:ext cx="5303520" cy="548640"/>
+          </a:xfrm>
+          <a:prstGeom prst="rect">
+            <a:avLst/>
+          </a:prstGeom>
+          <a:noFill/>
+        </p:spPr>
+        <p:txBody>
+          <a:bodyPr wrap="none">
+            <a:spAutoFit/>
+          </a:bodyPr>
+          <a:lstStyle/>
+          <a:p>
+            <a:r>
+              <a:rPr sz="2200" b="1">
+                <a:solidFill>
+                  <a:srgbClr val="FFD666"/>
+                </a:solidFill>
+              </a:rPr>
+              <a:t>Contexte</a:t>
+            </a:r>
+          </a:p>
+        </p:txBody>
+      </p:sp>
+      <p:sp>
+        <p:nvSpPr>
+          <p:cNvPr id="4" name="TextBox 3"/>
+          <p:cNvSpPr txBox="1"/>
+          <p:nvPr/>
+        </p:nvSpPr>
+        <p:spPr>
+          <a:xfrm>
+            <a:off x="640080" y="2514600"/>
+            <a:ext cx="5303520" cy="4206240"/>
+          </a:xfrm>
+          <a:prstGeom prst="rect">
+            <a:avLst/>
+          </a:prstGeom>
+          <a:noFill/>
+        </p:spPr>
+        <p:txBody>
+          <a:bodyPr wrap="square">
+            <a:spAutoFit/>
+          </a:bodyPr>
+          <a:lstStyle/>
+          <a:p>
+            <a:pPr>
+              <a:spcAft>
+                <a:spcPts val="1000"/>
+              </a:spcAft>
+              <a:defRPr sz="1800">
+                <a:solidFill>
+                  <a:srgbClr val="E8F0FF"/>
+                </a:solidFill>
+              </a:defRPr>
+            </a:pPr>
+            <a:r>
+              <a:t>Direction souhaite un etat de progression finance lisible.</a:t>
+            </a:r>
+          </a:p>
+        </p:txBody>
+      </p:sp>
+      <p:sp>
+        <p:nvSpPr>
+          <p:cNvPr id="5" name="TextBox 4"/>
+          <p:cNvSpPr txBox="1"/>
+          <p:nvPr/>
+        </p:nvSpPr>
+        <p:spPr>
+          <a:xfrm>
+            <a:off x="6126480" y="1828800"/>
+            <a:ext cx="5303520" cy="548640"/>
+          </a:xfrm>
+          <a:prstGeom prst="rect">
+            <a:avLst/>
+          </a:prstGeom>
+          <a:noFill/>
+        </p:spPr>
+        <p:txBody>
+          <a:bodyPr wrap="none">
+            <a:spAutoFit/>
+          </a:bodyPr>
+          <a:lstStyle/>
+          <a:p>
+            <a:r>
+              <a:rPr sz="2200" b="1">
+                <a:solidFill>
+                  <a:srgbClr val="FFD666"/>
+                </a:solidFill>
+              </a:rPr>
+              <a:t>Action dans le cockpit SAP</a:t>
+            </a:r>
+          </a:p>
+        </p:txBody>
+      </p:sp>
+      <p:sp>
+        <p:nvSpPr>
+          <p:cNvPr id="6" name="TextBox 5"/>
+          <p:cNvSpPr txBox="1"/>
+          <p:nvPr/>
+        </p:nvSpPr>
+        <p:spPr>
+          <a:xfrm>
+            <a:off x="6126480" y="2514600"/>
+            <a:ext cx="5303520" cy="4206240"/>
+          </a:xfrm>
+          <a:prstGeom prst="rect">
+            <a:avLst/>
+          </a:prstGeom>
+          <a:noFill/>
+        </p:spPr>
+        <p:txBody>
+          <a:bodyPr wrap="square">
+            <a:spAutoFit/>
+          </a:bodyPr>
+          <a:lstStyle/>
+          <a:p>
+            <a:pPr>
+              <a:spcAft>
+                <a:spcPts val="1000"/>
+              </a:spcAft>
+              <a:defRPr sz="1800">
+                <a:solidFill>
+                  <a:srgbClr val="E8F0FF"/>
+                </a:solidFill>
+              </a:defRPr>
+            </a:pPr>
+            <a:r>
+              <a:t>Utiliser cockpit comme support de comite: score, risques, plan suivant.</a:t>
+            </a:r>
+          </a:p>
+        </p:txBody>
+      </p:sp>
+      <p:sp>
+        <p:nvSpPr>
+          <p:cNvPr id="7" name="TextBox 6"/>
+          <p:cNvSpPr txBox="1"/>
+          <p:nvPr/>
+        </p:nvSpPr>
+        <p:spPr>
+          <a:xfrm>
+            <a:off x="640080" y="4800600"/>
+            <a:ext cx="10789920" cy="548640"/>
+          </a:xfrm>
+          <a:prstGeom prst="rect">
+            <a:avLst/>
+          </a:prstGeom>
+          <a:noFill/>
+        </p:spPr>
+        <p:txBody>
+          <a:bodyPr wrap="none">
+            <a:spAutoFit/>
+          </a:bodyPr>
+          <a:lstStyle/>
+          <a:p>
+            <a:r>
+              <a:rPr sz="2200" b="1">
+                <a:solidFill>
+                  <a:srgbClr val="FFD666"/>
+                </a:solidFill>
+              </a:rPr>
+              <a:t>Resultat attendu</a:t>
+            </a:r>
+          </a:p>
+        </p:txBody>
+      </p:sp>
+      <p:sp>
+        <p:nvSpPr>
+          <p:cNvPr id="8" name="TextBox 7"/>
+          <p:cNvSpPr txBox="1"/>
+          <p:nvPr/>
+        </p:nvSpPr>
+        <p:spPr>
+          <a:xfrm>
+            <a:off x="640080" y="5486400"/>
+            <a:ext cx="10789920" cy="1097280"/>
+          </a:xfrm>
+          <a:prstGeom prst="rect">
+            <a:avLst/>
+          </a:prstGeom>
+          <a:noFill/>
+        </p:spPr>
+        <p:txBody>
+          <a:bodyPr wrap="square">
+            <a:spAutoFit/>
+          </a:bodyPr>
+          <a:lstStyle/>
+          <a:p>
+            <a:pPr>
+              <a:spcAft>
+                <a:spcPts val="1000"/>
+              </a:spcAft>
+              <a:defRPr sz="1800">
+                <a:solidFill>
+                  <a:srgbClr val="E8F0FF"/>
+                </a:solidFill>
+              </a:defRPr>
+            </a:pPr>
+            <a:r>
+              <a:t>Decisions plus rapides et alignement transversal.</a:t>
+            </a:r>
+          </a:p>
+          <a:p>
+            <a:pPr>
+              <a:spcAft>
+                <a:spcPts val="1000"/>
+              </a:spcAft>
+              <a:defRPr sz="1800">
+                <a:solidFill>
+                  <a:srgbClr val="E8F0FF"/>
+                </a:solidFill>
+              </a:defRPr>
+            </a:pPr>
+            <a:r>
+              <a:t>Indicateurs: Global score, top 3 risques, plan du mois suivant valide.</a:t>
+            </a:r>
+          </a:p>
+        </p:txBody>
+      </p:sp>
+      <p:sp>
+        <p:nvSpPr>
+          <p:cNvPr id="9" name="TextBox 8"/>
+          <p:cNvSpPr txBox="1"/>
+          <p:nvPr/>
+        </p:nvSpPr>
+        <p:spPr>
+          <a:xfrm>
+            <a:off x="640080" y="6126480"/>
+            <a:ext cx="10972800" cy="365760"/>
+          </a:xfrm>
+          <a:prstGeom prst="rect">
+            <a:avLst/>
+          </a:prstGeom>
+          <a:noFill/>
+        </p:spPr>
+        <p:txBody>
+          <a:bodyPr wrap="none">
+            <a:spAutoFit/>
+          </a:bodyPr>
+          <a:lstStyle/>
+          <a:p>
+            <a:pPr algn="r"/>
+            <a:r>
+              <a:rPr sz="1200">
+                <a:solidFill>
+                  <a:srgbClr val="8CA0BE"/>
+                </a:solidFill>
+              </a:rPr>
+              <a:t>CashPilot • Module SAP • Guide Novices</a:t>
+            </a:r>
+          </a:p>
+        </p:txBody>
+      </p:sp>
+    </p:spTree>
+  </p:cSld>
+  <p:clrMapOvr>
+    <a:masterClrMapping/>
+  </p:clrMapOvr>
+</p:sld>
+</file>
+
+<file path=ppt/slides/slide16.xml><?xml version="1.0" encoding="utf-8"?>
+<p:sld xmlns:a="http://schemas.openxmlformats.org/drawingml/2006/main" xmlns:p="http://schemas.openxmlformats.org/presentationml/2006/main" xmlns:r="http://schemas.openxmlformats.org/officeDocument/2006/relationships">
+  <p:cSld>
+    <p:bg>
+      <p:bgPr>
+        <a:solidFill>
+          <a:srgbClr val="09122B"/>
+        </a:solidFill>
+        <a:effectLst/>
+      </p:bgPr>
+    </p:bg>
+    <p:spTree>
+      <p:nvGrpSpPr>
+        <p:cNvPr id="1" name=""/>
+        <p:cNvGrpSpPr/>
+        <p:nvPr/>
+      </p:nvGrpSpPr>
+      <p:grpSpPr/>
+      <p:sp>
+        <p:nvSpPr>
+          <p:cNvPr id="2" name="TextBox 1"/>
+          <p:cNvSpPr txBox="1"/>
+          <p:nvPr/>
+        </p:nvSpPr>
+        <p:spPr>
+          <a:xfrm>
+            <a:off x="640080" y="457200"/>
+            <a:ext cx="10972800" cy="1097280"/>
+          </a:xfrm>
+          <a:prstGeom prst="rect">
+            <a:avLst/>
+          </a:prstGeom>
+          <a:noFill/>
+        </p:spPr>
+        <p:txBody>
+          <a:bodyPr wrap="none">
+            <a:spAutoFit/>
+          </a:bodyPr>
+          <a:lstStyle/>
+          <a:p>
+            <a:pPr algn="l"/>
+            <a:r>
+              <a:rPr sz="3600" b="1">
+                <a:solidFill>
+                  <a:srgbClr val="FFFFFF"/>
+                </a:solidFill>
+              </a:rPr>
               <a:t>Synthese</a:t>
             </a:r>
           </a:p>
@@ -5443,7 +5766,7 @@
                   <a:srgbClr val="FFFFFF"/>
                 </a:solidFill>
               </a:rPr>
-              <a:t>Quand utiliser le cockpit SAP</a:t>
+              <a:t>Definitions simples des sigles SAP</a:t>
             </a:r>
           </a:p>
         </p:txBody>
@@ -5476,7 +5799,7 @@
                   <a:srgbClr val="FFD666"/>
                 </a:solidFill>
               </a:rPr>
-              <a:t>Moments clefs</a:t>
+              <a:t>Glossaire FI / CO / AA</a:t>
             </a:r>
           </a:p>
         </p:txBody>
@@ -5514,7 +5837,7 @@
               </a:defRPr>
             </a:pPr>
             <a:r>
-              <a:t>Au demarrage d'une nouvelle societe</a:t>
+              <a:t>FI (Finance Accounting): comptabilite generale, ecritures, TVA, rapprochements.</a:t>
             </a:r>
           </a:p>
           <a:p>
@@ -5529,7 +5852,7 @@
               </a:defRPr>
             </a:pPr>
             <a:r>
-              <a:t>En revue hebdomadaire ou mensuelle CFO/compta</a:t>
+              <a:t>CO (Controlling): axes analytiques pour piloter couts, marges et performance.</a:t>
             </a:r>
           </a:p>
           <a:p>
@@ -5544,7 +5867,7 @@
               </a:defRPr>
             </a:pPr>
             <a:r>
-              <a:t>Avant la cloture de periode</a:t>
+              <a:t>AA (Asset Accounting): immobilisations, amortissements et suivi des actifs.</a:t>
             </a:r>
           </a:p>
           <a:p>
@@ -5559,7 +5882,7 @@
               </a:defRPr>
             </a:pPr>
             <a:r>
-              <a:t>Pendant une transformation finance multi-entites</a:t>
+              <a:t>Consolidation: pilotage multi-entites et intercompany.</a:t>
             </a:r>
           </a:p>
           <a:p>
@@ -5574,7 +5897,7 @@
               </a:defRPr>
             </a:pPr>
             <a:r>
-              <a:t>Pour onboarder des utilisateurs non-comptables</a:t>
+              <a:t>Close: orchestration de la cloture periodique et de la conformite.</a:t>
             </a:r>
           </a:p>
         </p:txBody>
@@ -5668,7 +5991,7 @@
                   <a:srgbClr val="FFFFFF"/>
                 </a:solidFill>
               </a:rPr>
-              <a:t>Plus-value SAP pour CashPilot</a:t>
+              <a:t>Quand utiliser le cockpit SAP</a:t>
             </a:r>
           </a:p>
         </p:txBody>
@@ -5681,8 +6004,8 @@
         </p:nvSpPr>
         <p:spPr>
           <a:xfrm>
-            <a:off x="640080" y="1828800"/>
-            <a:ext cx="5303520" cy="548640"/>
+            <a:off x="731520" y="2194560"/>
+            <a:ext cx="10972800" cy="548640"/>
           </a:xfrm>
           <a:prstGeom prst="rect">
             <a:avLst/>
@@ -5701,7 +6024,7 @@
                   <a:srgbClr val="FFD666"/>
                 </a:solidFill>
               </a:rPr>
-              <a:t>Valeur operationnelle</a:t>
+              <a:t>Moments clefs</a:t>
             </a:r>
           </a:p>
         </p:txBody>
@@ -5714,8 +6037,8 @@
         </p:nvSpPr>
         <p:spPr>
           <a:xfrm>
-            <a:off x="640080" y="2514600"/>
-            <a:ext cx="5303520" cy="4206240"/>
+            <a:off x="731520" y="2880360"/>
+            <a:ext cx="10972800" cy="4023360"/>
           </a:xfrm>
           <a:prstGeom prst="rect">
             <a:avLst/>
@@ -5739,7 +6062,7 @@
               </a:defRPr>
             </a:pPr>
             <a:r>
-              <a:t>Vision unique des priorites</a:t>
+              <a:t>Au demarrage d'une nouvelle societe</a:t>
             </a:r>
           </a:p>
           <a:p>
@@ -5754,7 +6077,7 @@
               </a:defRPr>
             </a:pPr>
             <a:r>
-              <a:t>Execution guidee via workstreams</a:t>
+              <a:t>En revue hebdomadaire ou mensuelle CFO/compta</a:t>
             </a:r>
           </a:p>
           <a:p>
@@ -5769,7 +6092,7 @@
               </a:defRPr>
             </a:pPr>
             <a:r>
-              <a:t>Suivi factuel par score et statut</a:t>
+              <a:t>Avant la cloture de periode</a:t>
             </a:r>
           </a:p>
           <a:p>
@@ -5784,65 +6107,9 @@
               </a:defRPr>
             </a:pPr>
             <a:r>
-              <a:t>Reduction des blocages et retards</a:t>
-            </a:r>
-          </a:p>
-        </p:txBody>
-      </p:sp>
-      <p:sp>
-        <p:nvSpPr>
-          <p:cNvPr id="5" name="TextBox 4"/>
-          <p:cNvSpPr txBox="1"/>
-          <p:nvPr/>
-        </p:nvSpPr>
-        <p:spPr>
-          <a:xfrm>
-            <a:off x="6126480" y="1828800"/>
-            <a:ext cx="5303520" cy="548640"/>
-          </a:xfrm>
-          <a:prstGeom prst="rect">
-            <a:avLst/>
-          </a:prstGeom>
-          <a:noFill/>
-        </p:spPr>
-        <p:txBody>
-          <a:bodyPr wrap="none">
-            <a:spAutoFit/>
-          </a:bodyPr>
-          <a:lstStyle/>
-          <a:p>
-            <a:r>
-              <a:rPr sz="2200" b="1">
-                <a:solidFill>
-                  <a:srgbClr val="FFD666"/>
-                </a:solidFill>
-              </a:rPr>
-              <a:t>Valeur humaine</a:t>
-            </a:r>
-          </a:p>
-        </p:txBody>
-      </p:sp>
-      <p:sp>
-        <p:nvSpPr>
-          <p:cNvPr id="6" name="TextBox 5"/>
-          <p:cNvSpPr txBox="1"/>
-          <p:nvPr/>
-        </p:nvSpPr>
-        <p:spPr>
-          <a:xfrm>
-            <a:off x="6126480" y="2514600"/>
-            <a:ext cx="5303520" cy="4206240"/>
-          </a:xfrm>
-          <a:prstGeom prst="rect">
-            <a:avLst/>
-          </a:prstGeom>
-          <a:noFill/>
-        </p:spPr>
-        <p:txBody>
-          <a:bodyPr wrap="square">
-            <a:spAutoFit/>
-          </a:bodyPr>
-          <a:lstStyle/>
+              <a:t>Pendant une transformation finance multi-entites</a:t>
+            </a:r>
+          </a:p>
           <a:p>
             <a:pPr>
               <a:spcAft>
@@ -5855,59 +6122,14 @@
               </a:defRPr>
             </a:pPr>
             <a:r>
-              <a:t>Lecture simplifiee pour novices</a:t>
-            </a:r>
-          </a:p>
-          <a:p>
-            <a:pPr>
-              <a:spcAft>
-                <a:spcPts val="1000"/>
-              </a:spcAft>
-              <a:defRPr sz="1800">
-                <a:solidFill>
-                  <a:srgbClr val="E8F0FF"/>
-                </a:solidFill>
-              </a:defRPr>
-            </a:pPr>
-            <a:r>
-              <a:t>Alignement CFO, compta, ops</a:t>
-            </a:r>
-          </a:p>
-          <a:p>
-            <a:pPr>
-              <a:spcAft>
-                <a:spcPts val="1000"/>
-              </a:spcAft>
-              <a:defRPr sz="1800">
-                <a:solidFill>
-                  <a:srgbClr val="E8F0FF"/>
-                </a:solidFill>
-              </a:defRPr>
-            </a:pPr>
-            <a:r>
-              <a:t>Moins de dependance a l'expert unique</a:t>
-            </a:r>
-          </a:p>
-          <a:p>
-            <a:pPr>
-              <a:spcAft>
-                <a:spcPts val="1000"/>
-              </a:spcAft>
-              <a:defRPr sz="1800">
-                <a:solidFill>
-                  <a:srgbClr val="E8F0FF"/>
-                </a:solidFill>
-              </a:defRPr>
-            </a:pPr>
-            <a:r>
-              <a:t>Montee en competence plus rapide</a:t>
-            </a:r>
-          </a:p>
-        </p:txBody>
-      </p:sp>
-      <p:sp>
-        <p:nvSpPr>
-          <p:cNvPr id="7" name="TextBox 6"/>
+              <a:t>Pour onboarder des utilisateurs non-comptables</a:t>
+            </a:r>
+          </a:p>
+        </p:txBody>
+      </p:sp>
+      <p:sp>
+        <p:nvSpPr>
+          <p:cNvPr id="5" name="TextBox 4"/>
           <p:cNvSpPr txBox="1"/>
           <p:nvPr/>
         </p:nvSpPr>
@@ -5994,7 +6216,7 @@
                   <a:srgbClr val="FFFFFF"/>
                 </a:solidFill>
               </a:rPr>
-              <a:t>Cas d'usage 1: Demarrage d'une nouvelle societe</a:t>
+              <a:t>Plus-value SAP pour CashPilot</a:t>
             </a:r>
           </a:p>
         </p:txBody>
@@ -6027,7 +6249,7 @@
                   <a:srgbClr val="FFD666"/>
                 </a:solidFill>
               </a:rPr>
-              <a:t>Contexte</a:t>
+              <a:t>Valeur operationnelle</a:t>
             </a:r>
           </a:p>
         </p:txBody>
@@ -6065,65 +6287,9 @@
               </a:defRPr>
             </a:pPr>
             <a:r>
-              <a:t>La societe part de zero et doit fiabiliser sa base comptable rapidement.</a:t>
-            </a:r>
-          </a:p>
-        </p:txBody>
-      </p:sp>
-      <p:sp>
-        <p:nvSpPr>
-          <p:cNvPr id="5" name="TextBox 4"/>
-          <p:cNvSpPr txBox="1"/>
-          <p:nvPr/>
-        </p:nvSpPr>
-        <p:spPr>
-          <a:xfrm>
-            <a:off x="6126480" y="1828800"/>
-            <a:ext cx="5303520" cy="548640"/>
-          </a:xfrm>
-          <a:prstGeom prst="rect">
-            <a:avLst/>
-          </a:prstGeom>
-          <a:noFill/>
-        </p:spPr>
-        <p:txBody>
-          <a:bodyPr wrap="none">
-            <a:spAutoFit/>
-          </a:bodyPr>
-          <a:lstStyle/>
-          <a:p>
-            <a:r>
-              <a:rPr sz="2200" b="1">
-                <a:solidFill>
-                  <a:srgbClr val="FFD666"/>
-                </a:solidFill>
-              </a:rPr>
-              <a:t>Action dans le cockpit SAP</a:t>
-            </a:r>
-          </a:p>
-        </p:txBody>
-      </p:sp>
-      <p:sp>
-        <p:nvSpPr>
-          <p:cNvPr id="6" name="TextBox 5"/>
-          <p:cNvSpPr txBox="1"/>
-          <p:nvPr/>
-        </p:nvSpPr>
-        <p:spPr>
-          <a:xfrm>
-            <a:off x="6126480" y="2514600"/>
-            <a:ext cx="5303520" cy="4206240"/>
-          </a:xfrm>
-          <a:prstGeom prst="rect">
-            <a:avLst/>
-          </a:prstGeom>
-          <a:noFill/>
-        </p:spPr>
-        <p:txBody>
-          <a:bodyPr wrap="square">
-            <a:spAutoFit/>
-          </a:bodyPr>
-          <a:lstStyle/>
+              <a:t>Vision unique des priorites</a:t>
+            </a:r>
+          </a:p>
           <a:p>
             <a:pPr>
               <a:spcAft>
@@ -6136,65 +6302,9 @@
               </a:defRPr>
             </a:pPr>
             <a:r>
-              <a:t>Prioriser FI dans le cockpit, creer workstreams sur plan comptable, mappings et ecritures initiales.</a:t>
-            </a:r>
-          </a:p>
-        </p:txBody>
-      </p:sp>
-      <p:sp>
-        <p:nvSpPr>
-          <p:cNvPr id="7" name="TextBox 6"/>
-          <p:cNvSpPr txBox="1"/>
-          <p:nvPr/>
-        </p:nvSpPr>
-        <p:spPr>
-          <a:xfrm>
-            <a:off x="640080" y="4800600"/>
-            <a:ext cx="10789920" cy="548640"/>
-          </a:xfrm>
-          <a:prstGeom prst="rect">
-            <a:avLst/>
-          </a:prstGeom>
-          <a:noFill/>
-        </p:spPr>
-        <p:txBody>
-          <a:bodyPr wrap="none">
-            <a:spAutoFit/>
-          </a:bodyPr>
-          <a:lstStyle/>
-          <a:p>
-            <a:r>
-              <a:rPr sz="2200" b="1">
-                <a:solidFill>
-                  <a:srgbClr val="FFD666"/>
-                </a:solidFill>
-              </a:rPr>
-              <a:t>Resultat attendu</a:t>
-            </a:r>
-          </a:p>
-        </p:txBody>
-      </p:sp>
-      <p:sp>
-        <p:nvSpPr>
-          <p:cNvPr id="8" name="TextBox 7"/>
-          <p:cNvSpPr txBox="1"/>
-          <p:nvPr/>
-        </p:nvSpPr>
-        <p:spPr>
-          <a:xfrm>
-            <a:off x="640080" y="5486400"/>
-            <a:ext cx="10789920" cy="1097280"/>
-          </a:xfrm>
-          <a:prstGeom prst="rect">
-            <a:avLst/>
-          </a:prstGeom>
-          <a:noFill/>
-        </p:spPr>
-        <p:txBody>
-          <a:bodyPr wrap="square">
-            <a:spAutoFit/>
-          </a:bodyPr>
-          <a:lstStyle/>
+              <a:t>Execution guidee via workstreams</a:t>
+            </a:r>
+          </a:p>
           <a:p>
             <a:pPr>
               <a:spcAft>
@@ -6207,7 +6317,7 @@
               </a:defRPr>
             </a:pPr>
             <a:r>
-              <a:t>Base comptable exploitable des le premier cycle de pilotage.</a:t>
+              <a:t>Suivi factuel par score et statut</a:t>
             </a:r>
           </a:p>
           <a:p>
@@ -6222,14 +6332,130 @@
               </a:defRPr>
             </a:pPr>
             <a:r>
-              <a:t>Indicateurs: Score FI, total done, reduction des workstreams planned.</a:t>
-            </a:r>
-          </a:p>
-        </p:txBody>
-      </p:sp>
-      <p:sp>
-        <p:nvSpPr>
-          <p:cNvPr id="9" name="TextBox 8"/>
+              <a:t>Reduction des blocages et retards</a:t>
+            </a:r>
+          </a:p>
+        </p:txBody>
+      </p:sp>
+      <p:sp>
+        <p:nvSpPr>
+          <p:cNvPr id="5" name="TextBox 4"/>
+          <p:cNvSpPr txBox="1"/>
+          <p:nvPr/>
+        </p:nvSpPr>
+        <p:spPr>
+          <a:xfrm>
+            <a:off x="6126480" y="1828800"/>
+            <a:ext cx="5303520" cy="548640"/>
+          </a:xfrm>
+          <a:prstGeom prst="rect">
+            <a:avLst/>
+          </a:prstGeom>
+          <a:noFill/>
+        </p:spPr>
+        <p:txBody>
+          <a:bodyPr wrap="none">
+            <a:spAutoFit/>
+          </a:bodyPr>
+          <a:lstStyle/>
+          <a:p>
+            <a:r>
+              <a:rPr sz="2200" b="1">
+                <a:solidFill>
+                  <a:srgbClr val="FFD666"/>
+                </a:solidFill>
+              </a:rPr>
+              <a:t>Valeur humaine</a:t>
+            </a:r>
+          </a:p>
+        </p:txBody>
+      </p:sp>
+      <p:sp>
+        <p:nvSpPr>
+          <p:cNvPr id="6" name="TextBox 5"/>
+          <p:cNvSpPr txBox="1"/>
+          <p:nvPr/>
+        </p:nvSpPr>
+        <p:spPr>
+          <a:xfrm>
+            <a:off x="6126480" y="2514600"/>
+            <a:ext cx="5303520" cy="4206240"/>
+          </a:xfrm>
+          <a:prstGeom prst="rect">
+            <a:avLst/>
+          </a:prstGeom>
+          <a:noFill/>
+        </p:spPr>
+        <p:txBody>
+          <a:bodyPr wrap="square">
+            <a:spAutoFit/>
+          </a:bodyPr>
+          <a:lstStyle/>
+          <a:p>
+            <a:pPr>
+              <a:spcAft>
+                <a:spcPts val="1000"/>
+              </a:spcAft>
+              <a:defRPr sz="1800">
+                <a:solidFill>
+                  <a:srgbClr val="E8F0FF"/>
+                </a:solidFill>
+              </a:defRPr>
+            </a:pPr>
+            <a:r>
+              <a:t>Lecture simplifiee pour novices</a:t>
+            </a:r>
+          </a:p>
+          <a:p>
+            <a:pPr>
+              <a:spcAft>
+                <a:spcPts val="1000"/>
+              </a:spcAft>
+              <a:defRPr sz="1800">
+                <a:solidFill>
+                  <a:srgbClr val="E8F0FF"/>
+                </a:solidFill>
+              </a:defRPr>
+            </a:pPr>
+            <a:r>
+              <a:t>Alignement CFO, compta, ops</a:t>
+            </a:r>
+          </a:p>
+          <a:p>
+            <a:pPr>
+              <a:spcAft>
+                <a:spcPts val="1000"/>
+              </a:spcAft>
+              <a:defRPr sz="1800">
+                <a:solidFill>
+                  <a:srgbClr val="E8F0FF"/>
+                </a:solidFill>
+              </a:defRPr>
+            </a:pPr>
+            <a:r>
+              <a:t>Moins de dependance a l'expert unique</a:t>
+            </a:r>
+          </a:p>
+          <a:p>
+            <a:pPr>
+              <a:spcAft>
+                <a:spcPts val="1000"/>
+              </a:spcAft>
+              <a:defRPr sz="1800">
+                <a:solidFill>
+                  <a:srgbClr val="E8F0FF"/>
+                </a:solidFill>
+              </a:defRPr>
+            </a:pPr>
+            <a:r>
+              <a:t>Montee en competence plus rapide</a:t>
+            </a:r>
+          </a:p>
+        </p:txBody>
+      </p:sp>
+      <p:sp>
+        <p:nvSpPr>
+          <p:cNvPr id="7" name="TextBox 6"/>
           <p:cNvSpPr txBox="1"/>
           <p:nvPr/>
         </p:nvSpPr>
@@ -6316,7 +6542,7 @@
                   <a:srgbClr val="FFFFFF"/>
                 </a:solidFill>
               </a:rPr>
-              <a:t>Cas d'usage 2: Stabilisation des ecritures FI</a:t>
+              <a:t>Cas d'usage 1: Demarrage d'une nouvelle societe</a:t>
             </a:r>
           </a:p>
         </p:txBody>
@@ -6387,7 +6613,7 @@
               </a:defRPr>
             </a:pPr>
             <a:r>
-              <a:t>Incoherences entre pieces et ecritures, difficultes de suivi.</a:t>
+              <a:t>La societe part de zero et doit fiabiliser sa base comptable rapidement.</a:t>
             </a:r>
           </a:p>
         </p:txBody>
@@ -6458,7 +6684,7 @@
               </a:defRPr>
             </a:pPr>
             <a:r>
-              <a:t>Analyser metriques FI puis traiter les actions bloquees/overdue en roadmap.</a:t>
+              <a:t>Prioriser FI dans le cockpit, creer workstreams sur plan comptable, mappings et ecritures initiales.</a:t>
             </a:r>
           </a:p>
         </p:txBody>
@@ -6529,7 +6755,7 @@
               </a:defRPr>
             </a:pPr>
             <a:r>
-              <a:t>Qualite des ecritures amelioree et meilleure fiabilite du reporting.</a:t>
+              <a:t>Base comptable exploitable des le premier cycle de pilotage.</a:t>
             </a:r>
           </a:p>
           <a:p>
@@ -6544,7 +6770,7 @@
               </a:defRPr>
             </a:pPr>
             <a:r>
-              <a:t>Indicateurs: Entries, last entry, baisse des workstreams blocked.</a:t>
+              <a:t>Indicateurs: Score FI, total done, reduction des workstreams planned.</a:t>
             </a:r>
           </a:p>
         </p:txBody>
@@ -6638,7 +6864,7 @@
                   <a:srgbClr val="FFFFFF"/>
                 </a:solidFill>
               </a:rPr>
-              <a:t>Cas d'usage 3: Mise en place du controlling CO</a:t>
+              <a:t>Cas d'usage 2: Stabilisation des ecritures FI</a:t>
             </a:r>
           </a:p>
         </p:txBody>
@@ -6709,7 +6935,7 @@
               </a:defRPr>
             </a:pPr>
             <a:r>
-              <a:t>Absence d'axes analytiques pour suivre la performance.</a:t>
+              <a:t>Incoherences entre pieces et ecritures, difficultes de suivi.</a:t>
             </a:r>
           </a:p>
         </p:txBody>
@@ -6780,7 +7006,7 @@
               </a:defRPr>
             </a:pPr>
             <a:r>
-              <a:t>Activer CO, definir axes et deployer les regles analytiques par workstreams.</a:t>
+              <a:t>Analyser metriques FI puis traiter les actions bloquees/overdue en roadmap.</a:t>
             </a:r>
           </a:p>
         </p:txBody>
@@ -6851,7 +7077,7 @@
               </a:defRPr>
             </a:pPr>
             <a:r>
-              <a:t>Lecture des couts et marges par axe metier.</a:t>
+              <a:t>Qualite des ecritures amelioree et meilleure fiabilite du reporting.</a:t>
             </a:r>
           </a:p>
           <a:p>
@@ -6866,7 +7092,7 @@
               </a:defRPr>
             </a:pPr>
             <a:r>
-              <a:t>Indicateurs: Axes analytiques, score CO, taux de completion des actions.</a:t>
+              <a:t>Indicateurs: Entries, last entry, baisse des workstreams blocked.</a:t>
             </a:r>
           </a:p>
         </p:txBody>
@@ -6960,7 +7186,7 @@
                   <a:srgbClr val="FFFFFF"/>
                 </a:solidFill>
               </a:rPr>
-              <a:t>Cas d'usage 4: Structuration des immobilisations AA</a:t>
+              <a:t>Cas d'usage 3: Mise en place du controlling CO</a:t>
             </a:r>
           </a:p>
         </p:txBody>
@@ -7031,7 +7257,7 @@
               </a:defRPr>
             </a:pPr>
             <a:r>
-              <a:t>Les actifs sont suivis en dehors du systeme.</a:t>
+              <a:t>Absence d'axes analytiques pour suivre la performance.</a:t>
             </a:r>
           </a:p>
         </p:txBody>
@@ -7102,7 +7328,7 @@
               </a:defRPr>
             </a:pPr>
             <a:r>
-              <a:t>Lancer module AA, inventorier les actifs et planifier la reprise en base.</a:t>
+              <a:t>Activer CO, definir axes et deployer les regles analytiques par workstreams.</a:t>
             </a:r>
           </a:p>
         </p:txBody>
@@ -7173,7 +7399,7 @@
               </a:defRPr>
             </a:pPr>
             <a:r>
-              <a:t>Gestion des immobilisations centralisee et traçable.</a:t>
+              <a:t>Lecture des couts et marges par axe metier.</a:t>
             </a:r>
           </a:p>
           <a:p>
@@ -7188,7 +7414,7 @@
               </a:defRPr>
             </a:pPr>
             <a:r>
-              <a:t>Indicateurs: Assets count, score AA, workstreams done.</a:t>
+              <a:t>Indicateurs: Axes analytiques, score CO, taux de completion des actions.</a:t>
             </a:r>
           </a:p>
         </p:txBody>
@@ -7282,7 +7508,7 @@
                   <a:srgbClr val="FFFFFF"/>
                 </a:solidFill>
               </a:rPr>
-              <a:t>Cas d'usage 5: Preparation de cloture periodique</a:t>
+              <a:t>Cas d'usage 4: Structuration des immobilisations AA</a:t>
             </a:r>
           </a:p>
         </p:txBody>
@@ -7353,7 +7579,7 @@
               </a:defRPr>
             </a:pPr>
             <a:r>
-              <a:t>Clotures tardives et charge de fin de mois trop elevee.</a:t>
+              <a:t>Les actifs sont suivis en dehors du systeme.</a:t>
             </a:r>
           </a:p>
         </p:txBody>
@@ -7424,7 +7650,7 @@
               </a:defRPr>
             </a:pPr>
             <a:r>
-              <a:t>Utiliser module Close pour orchestrer checklist et dependances.</a:t>
+              <a:t>Lancer module AA, inventorier les actifs et planifier la reprise en base.</a:t>
             </a:r>
           </a:p>
         </p:txBody>
@@ -7495,7 +7721,7 @@
               </a:defRPr>
             </a:pPr>
             <a:r>
-              <a:t>Cloture plus predicible et reduction des retards.</a:t>
+              <a:t>Gestion des immobilisations centralisee et traçable.</a:t>
             </a:r>
           </a:p>
           <a:p>
@@ -7510,7 +7736,7 @@
               </a:defRPr>
             </a:pPr>
             <a:r>
-              <a:t>Indicateurs: Closures, latest closure, overdue proche de zero.</a:t>
+              <a:t>Indicateurs: Assets count, score AA, workstreams done.</a:t>
             </a:r>
           </a:p>
         </p:txBody>

</xml_diff>